<commit_message>
docs: cập nhật thông tin thành viên, kiến trúc Airflow và Kafka trên slide thuyết trình
</commit_message>
<xml_diff>
--- a/Bao_Cao_BigData_HUIT_15Slides.pptx
+++ b/Bao_Cao_BigData_HUIT_15Slides.pptx
@@ -3219,30 +3219,30 @@
               <a:spcAft>
                 <a:spcPts val="600"/>
               </a:spcAft>
-              <a:defRPr sz="2100" b="1">
+              <a:defRPr sz="2000" b="1">
                 <a:solidFill>
                   <a:srgbClr val="FFFFFF"/>
                 </a:solidFill>
               </a:defRPr>
             </a:pPr>
             <a:r>
-              <a:t>HỆ KHUYẾN NGHỊ SẢN PHẨM TRÊN SÀN THƯƠNG MẠI ĐIỆN TỬ</a:t>
+              <a:t>XÂY DỰNG HỆ THỐNG BIG DATA PHÂN TÁN CHO BÀI TOÁN KHUYẾN NGHỊ SẢN PHẨM</a:t>
             </a:r>
             <a:br/>
             <a:r>
-              <a:t>VỚI THUẬT TOÁN PHÂN TÁN ALS (APACHE SPARK &amp; HADOOP HDFS)</a:t>
-            </a:r>
-          </a:p>
-          <a:p>
-            <a:pPr>
-              <a:defRPr sz="1250">
+              <a:t>DỰA TRÊN HADOOP HDFS, APACHE SPARK, AIRFLOW VÀ ALS MLLIB</a:t>
+            </a:r>
+          </a:p>
+          <a:p>
+            <a:pPr>
+              <a:defRPr sz="1200">
                 <a:solidFill>
                   <a:srgbClr val="E3F2FD"/>
                 </a:solidFill>
               </a:defRPr>
             </a:pPr>
             <a:r>
-              <a:t>Bộ dữ liệu: RetailRocket E-Commerce (1.4 GB | 2,756,101 dòng tương tác | 1.4M Users x 235K Items)</a:t>
+              <a:t>Bộ dữ liệu: RetailRocket E-Commerce (1.4 GB | 2,756,101 dòng tương tác | 1 NameNode + 2 DataNodes | 1 Master + 2 Spark Workers)</a:t>
             </a:r>
           </a:p>
         </p:txBody>
@@ -3368,7 +3368,11 @@
               </a:defRPr>
             </a:pPr>
             <a:r>
-              <a:t>THÀNH VIÊN 1</a:t>
+              <a:t>NGUYỄN VĂN AN</a:t>
+            </a:r>
+            <a:br/>
+            <a:r>
+              <a:t>(2001210001)</a:t>
             </a:r>
           </a:p>
           <a:p>
@@ -3383,7 +3387,7 @@
               </a:defRPr>
             </a:pPr>
             <a:r>
-              <a:t>• Hạ tầng Phân tán HDFS</a:t>
+              <a:t>• Hạ tầng HDFS &amp; Ingestion</a:t>
             </a:r>
           </a:p>
           <a:p>
@@ -3428,7 +3432,7 @@
               </a:defRPr>
             </a:pPr>
             <a:r>
-              <a:t>• docker-compose, 00_init_hdfs</a:t>
+              <a:t>• Kafka Streaming Ingestion</a:t>
             </a:r>
           </a:p>
         </p:txBody>
@@ -3554,7 +3558,11 @@
               </a:defRPr>
             </a:pPr>
             <a:r>
-              <a:t>THÀNH VIÊN 2</a:t>
+              <a:t>TRẦN PHƯƠNG</a:t>
+            </a:r>
+            <a:br/>
+            <a:r>
+              <a:t>(2001210002)</a:t>
             </a:r>
           </a:p>
           <a:p>
@@ -3584,7 +3592,7 @@
               </a:defRPr>
             </a:pPr>
             <a:r>
-              <a:t>• Làm sạch rác, khử trùng lặp</a:t>
+              <a:t>• Làm sạch 2.75M dòng</a:t>
             </a:r>
           </a:p>
           <a:p>
@@ -3599,7 +3607,7 @@
               </a:defRPr>
             </a:pPr>
             <a:r>
-              <a:t>• Narrow vs Wide (Shuffle)</a:t>
+              <a:t>• Implicit Scoring (1/2/3)</a:t>
             </a:r>
           </a:p>
           <a:p>
@@ -3614,7 +3622,7 @@
               </a:defRPr>
             </a:pPr>
             <a:r>
-              <a:t>• Parquet Snappy (01_etl.py)</a:t>
+              <a:t>• Nén Parquet Snappy (01_etl.py)</a:t>
             </a:r>
           </a:p>
         </p:txBody>
@@ -3740,7 +3748,11 @@
               </a:defRPr>
             </a:pPr>
             <a:r>
-              <a:t>THÀNH VIÊN 3</a:t>
+              <a:t>TRẦN BẢO NGUYÊN</a:t>
+            </a:r>
+            <a:br/>
+            <a:r>
+              <a:t>(2001210003)</a:t>
             </a:r>
           </a:p>
           <a:p>
@@ -3755,7 +3767,7 @@
               </a:defRPr>
             </a:pPr>
             <a:r>
-              <a:t>• Học máy Spark MLlib ALS</a:t>
+              <a:t>• Spark MLlib ALS &amp; Benchmark</a:t>
             </a:r>
           </a:p>
           <a:p>
@@ -3770,7 +3782,7 @@
               </a:defRPr>
             </a:pPr>
             <a:r>
-              <a:t>• Matrix Factorization</a:t>
+              <a:t>• Matrix Factorization k=10</a:t>
             </a:r>
           </a:p>
           <a:p>
@@ -3785,7 +3797,7 @@
               </a:defRPr>
             </a:pPr>
             <a:r>
-              <a:t>• Implicit ALS (10 vòng lặp)</a:t>
+              <a:t>• Hội tụ RMSE ~ 0.02108</a:t>
             </a:r>
           </a:p>
           <a:p>
@@ -3800,7 +3812,7 @@
               </a:defRPr>
             </a:pPr>
             <a:r>
-              <a:t>• Hội tụ RMSE ~ 0.021</a:t>
+              <a:t>• Đo kiểm CSV vs Parquet (13.2x)</a:t>
             </a:r>
           </a:p>
         </p:txBody>
@@ -3926,7 +3938,11 @@
               </a:defRPr>
             </a:pPr>
             <a:r>
-              <a:t>THÀNH VIÊN 4</a:t>
+              <a:t>LÊ NGỌC ANH</a:t>
+            </a:r>
+            <a:br/>
+            <a:r>
+              <a:t>(2001210004)</a:t>
             </a:r>
           </a:p>
           <a:p>
@@ -3941,7 +3957,7 @@
               </a:defRPr>
             </a:pPr>
             <a:r>
-              <a:t>• Serving &amp; Benchmark</a:t>
+              <a:t>• Airflow DAG &amp; Serving UI</a:t>
             </a:r>
           </a:p>
           <a:p>
@@ -3971,7 +3987,7 @@
               </a:defRPr>
             </a:pPr>
             <a:r>
-              <a:t>• Đo kiểm CSV vs Parquet</a:t>
+              <a:t>• Airflow DAG (5 tasks liên hoàn)</a:t>
             </a:r>
           </a:p>
           <a:p>
@@ -3986,7 +4002,7 @@
               </a:defRPr>
             </a:pPr>
             <a:r>
-              <a:t>• Web Streamlit (app.py)</a:t>
+              <a:t>• Serving Web Streamlit (app.py)</a:t>
             </a:r>
           </a:p>
         </p:txBody>
@@ -6327,7 +6343,7 @@
               </a:defRPr>
             </a:pPr>
             <a:r>
-              <a:t>• Hoàn chỉnh cụm Docker Hadoop HDFS &amp; Spark phân tán.</a:t>
+              <a:t>• Hoàn chỉnh cụm Docker Hadoop HDFS (2 DataNodes) &amp; Spark (2 Workers).</a:t>
             </a:r>
           </a:p>
           <a:p>
@@ -6342,7 +6358,7 @@
               </a:defRPr>
             </a:pPr>
             <a:r>
-              <a:t>• Xử lý 2.75M dòng log; nén Parquet giảm 94.9% dung lượng, tăng tốc đọc 13.2 lần.</a:t>
+              <a:t>• Xử lý 2.75M dòng log; Parquet giảm 94.9% dung lượng, tăng tốc đọc 13.2 lần.</a:t>
             </a:r>
           </a:p>
           <a:p>
@@ -6357,7 +6373,22 @@
               </a:defRPr>
             </a:pPr>
             <a:r>
-              <a:t>• Mô hình ALS đạt RMSE ~ 0.021 (+75.3% so với Baseline), giải quyết triệt để Cold-Start.</a:t>
+              <a:t>• Mô hình ALS đạt RMSE ~ 0.021 (+75.2% vs Baseline), khắc phục Cold-Start.</a:t>
+            </a:r>
+          </a:p>
+          <a:p>
+            <a:pPr>
+              <a:spcAft>
+                <a:spcPts val="250"/>
+              </a:spcAft>
+              <a:defRPr sz="1100">
+                <a:solidFill>
+                  <a:srgbClr val="212529"/>
+                </a:solidFill>
+              </a:defRPr>
+            </a:pPr>
+            <a:r>
+              <a:t>• Tự động hóa bằng Airflow DAG (5/5 tasks SUCCESS), mô phỏng Kafka Streaming.</a:t>
             </a:r>
           </a:p>
         </p:txBody>
@@ -6528,7 +6559,7 @@
               </a:defRPr>
             </a:pPr>
             <a:r>
-              <a:t>• Pipeline hiện tại hoạt động theo Batch Processing, chưa học ngay lập tức khi có click mới.</a:t>
+              <a:t>• Mô hình học máy ALS tính toán theo Batch định kỳ, chưa cập nhật ma trận theo micro-giây.</a:t>
             </a:r>
           </a:p>
         </p:txBody>
@@ -6685,6 +6716,21 @@
             </a:pPr>
             <a:r>
               <a:t>• Xử lý thời gian thực: Tích hợp Apache Kafka và Spark Structured Streaming cập nhật gợi ý tức thời.</a:t>
+            </a:r>
+          </a:p>
+          <a:p>
+            <a:pPr>
+              <a:spcAft>
+                <a:spcPts val="250"/>
+              </a:spcAft>
+              <a:defRPr sz="1100">
+                <a:solidFill>
+                  <a:srgbClr val="212529"/>
+                </a:solidFill>
+              </a:defRPr>
+            </a:pPr>
+            <a:r>
+              <a:t>• Tích hợp Deep Learning: Neural Collaborative Filtering (NCF) tăng cường độ chính xác.</a:t>
             </a:r>
           </a:p>
         </p:txBody>
@@ -6999,7 +7045,37 @@
               </a:defRPr>
             </a:pPr>
             <a:r>
+              <a:t>• Apache Airflow Orchestration UI: http://localhost:8089  (Kiểm tra đồ thị DAG 5 tasks)</a:t>
+            </a:r>
+          </a:p>
+          <a:p>
+            <a:pPr>
+              <a:spcAft>
+                <a:spcPts val="250"/>
+              </a:spcAft>
+              <a:defRPr sz="1100">
+                <a:solidFill>
+                  <a:srgbClr val="212529"/>
+                </a:solidFill>
+              </a:defRPr>
+            </a:pPr>
+            <a:r>
               <a:t>• Streamlit Recommender Web App: http://localhost:8501  (Trải nghiệm gợi ý ALS &amp; Cold-Start)</a:t>
+            </a:r>
+          </a:p>
+          <a:p>
+            <a:pPr>
+              <a:spcAft>
+                <a:spcPts val="250"/>
+              </a:spcAft>
+              <a:defRPr sz="1100">
+                <a:solidFill>
+                  <a:srgbClr val="212529"/>
+                </a:solidFill>
+              </a:defRPr>
+            </a:pPr>
+            <a:r>
+              <a:t>• Kafka Streaming Topic: 'ecommerce_clickstream'  (Kiểm thử Producer &amp; Consumer)</a:t>
             </a:r>
           </a:p>
         </p:txBody>
@@ -10304,7 +10380,7 @@
               </a:defRPr>
             </a:pPr>
             <a:r>
-              <a:t>3.1. SƠ ĐỒ DATA PIPELINE TỔNG THỂ (5 BƯỚC KHÉP KÍN)</a:t>
+              <a:t>3.1. SƠ ĐỒ PIPELINE &amp; ĐIỀU PHỐI AIRFLOW DAG (5 BƯỚC KHÉP KÍN)</a:t>
             </a:r>
           </a:p>
         </p:txBody>
@@ -10475,7 +10551,7 @@
               </a:defRPr>
             </a:pPr>
             <a:r>
-              <a:t>• NameNode băm thành 12 Blocks (128MB).</a:t>
+              <a:t>• 12 Blocks (128MB), Rep=2.</a:t>
             </a:r>
           </a:p>
           <a:p>
@@ -10490,7 +10566,7 @@
               </a:defRPr>
             </a:pPr>
             <a:r>
-              <a:t>• Replication = 2 (24 Blocks vật lý).</a:t>
+              <a:t>• Mở rộng: Kafka Streaming (Producer &amp; Consumer).</a:t>
             </a:r>
           </a:p>
         </p:txBody>
@@ -10691,7 +10767,7 @@
               </a:defRPr>
             </a:pPr>
             <a:r>
-              <a:t>• Lưu Parquet nén Snappy.</a:t>
+              <a:t>• Lưu Parquet nén Snappy (72MB).</a:t>
             </a:r>
           </a:p>
         </p:txBody>
@@ -10832,7 +10908,7 @@
               </a:defRPr>
             </a:pPr>
             <a:r>
-              <a:t>• Script: 01b_spark_sql_top_products.py</a:t>
+              <a:t>• Script: 01b_spark_sql.py</a:t>
             </a:r>
           </a:p>
           <a:p>
@@ -10862,7 +10938,7 @@
               </a:defRPr>
             </a:pPr>
             <a:r>
-              <a:t>• Dùng Catalyst Optimizer tìm Top 10 SP tương tác cao nhất.</a:t>
+              <a:t>• Catalyst Optimizer tìm Top 10 SP tương tác cao nhất.</a:t>
             </a:r>
           </a:p>
           <a:p>
@@ -10877,7 +10953,7 @@
               </a:defRPr>
             </a:pPr>
             <a:r>
-              <a:t>• Giải quyết bài toán Cold-Start.</a:t>
+              <a:t>• Giải quyết triệt để Cold-Start.</a:t>
             </a:r>
           </a:p>
         </p:txBody>
@@ -11033,7 +11109,7 @@
               </a:defRPr>
             </a:pPr>
             <a:r>
-              <a:t>• Đọc Parquet sạch.</a:t>
+              <a:t>• Đọc Parquet nén Snappy.</a:t>
             </a:r>
           </a:p>
           <a:p>
@@ -11048,7 +11124,7 @@
               </a:defRPr>
             </a:pPr>
             <a:r>
-              <a:t>• Huấn luyện Implicit ALS (10 vòng lặp).</a:t>
+              <a:t>• Huấn luyện Implicit ALS 10 vòng.</a:t>
             </a:r>
           </a:p>
           <a:p>
@@ -11063,7 +11139,7 @@
               </a:defRPr>
             </a:pPr>
             <a:r>
-              <a:t>• Hội tụ RMSE ~ 0.021, lưu model xuống /spark/models.</a:t>
+              <a:t>• Hội tụ RMSE ~ 0.02108, lưu model vào /spark/models.</a:t>
             </a:r>
           </a:p>
         </p:txBody>
@@ -11189,7 +11265,7 @@
               </a:defRPr>
             </a:pPr>
             <a:r>
-              <a:t>BƯỚC 5: SERVING &amp; UI</a:t>
+              <a:t>BƯỚC 5: AIRFLOW &amp; UI</a:t>
             </a:r>
           </a:p>
           <a:p>
@@ -11204,7 +11280,7 @@
               </a:defRPr>
             </a:pPr>
             <a:r>
-              <a:t>• Script: 03_benchmark.py &amp; app.py</a:t>
+              <a:t>• recommender_pipeline_dag.py</a:t>
             </a:r>
           </a:p>
           <a:p>
@@ -11219,7 +11295,7 @@
               </a:defRPr>
             </a:pPr>
             <a:r>
-              <a:t>• Đo kiểm tốc độ đọc.</a:t>
+              <a:t>• Airflow điều phối 5 tasks tự động.</a:t>
             </a:r>
           </a:p>
           <a:p>
@@ -11234,7 +11310,22 @@
               </a:defRPr>
             </a:pPr>
             <a:r>
-              <a:t>• Web Streamlit nạp ALS Model suy diễn gợi ý mili-giây.</a:t>
+              <a:t>• 03_benchmark.py (13.2x speedup).</a:t>
+            </a:r>
+          </a:p>
+          <a:p>
+            <a:pPr>
+              <a:spcAft>
+                <a:spcPts val="250"/>
+              </a:spcAft>
+              <a:defRPr sz="1100">
+                <a:solidFill>
+                  <a:srgbClr val="212529"/>
+                </a:solidFill>
+              </a:defRPr>
+            </a:pPr>
+            <a:r>
+              <a:t>• Web Streamlit phục vụ thời gian thực (app.py).</a:t>
             </a:r>
           </a:p>
         </p:txBody>

</xml_diff>

<commit_message>
docs: cập nhật danh sách chính xác 4 thành viên và MSSV trên toàn bộ đồ án
</commit_message>
<xml_diff>
--- a/Bao_Cao_BigData_HUIT_15Slides.pptx
+++ b/Bao_Cao_BigData_HUIT_15Slides.pptx
@@ -3373,7 +3373,7 @@
             </a:r>
             <a:br/>
             <a:r>
-              <a:t>(2001210001)</a:t>
+              <a:t>(2001230313)</a:t>
             </a:r>
           </a:p>
           <a:p>
@@ -3559,11 +3559,11 @@
               </a:defRPr>
             </a:pPr>
             <a:r>
-              <a:t>TRẦN PHƯƠNG</a:t>
+              <a:t>TRẦN THỊ MINH PHƯƠNG</a:t>
             </a:r>
             <a:br/>
             <a:r>
-              <a:t>(2001210002)</a:t>
+              <a:t>(2001230704)</a:t>
             </a:r>
           </a:p>
           <a:p>
@@ -3753,7 +3753,7 @@
             </a:r>
             <a:br/>
             <a:r>
-              <a:t>(2001210003)</a:t>
+              <a:t>(2001230587)</a:t>
             </a:r>
           </a:p>
           <a:p>
@@ -3943,7 +3943,7 @@
             </a:r>
             <a:br/>
             <a:r>
-              <a:t>(2001210004)</a:t>
+              <a:t>(2001230017)</a:t>
             </a:r>
           </a:p>
           <a:p>

</xml_diff>